<commit_message>
feat: Introduce a presentation editor with support for creating shapes, applying click and hover actions, and managing hyperlinks.
</commit_message>
<xml_diff>
--- a/smoke_samples/07_tables.pptx
+++ b/smoke_samples/07_tables.pptx
@@ -262,9 +262,9 @@
                 <a:tableStyleId>{5C22544A-7EE6-4342-B048-85BDC9FD1C3A}</a:tableStyleId>
               </a:tblPr>
               <a:tblGrid>
-                <a:gridCol w="2000000"/>
-                <a:gridCol w="2000000"/>
-                <a:gridCol w="2000000"/>
+                <a:gridCol w="1828800"/>
+                <a:gridCol w="1828800"/>
+                <a:gridCol w="1828800"/>
               </a:tblGrid>
               <a:tr h="1066800">
                 <a:tc>

</xml_diff>